<commit_message>
docs(vong2): align voice claims with APK runtime
</commit_message>
<xml_diff>
--- a/docs/VIVA_Pitch_Vong2.pptx
+++ b/docs/VIVA_Pitch_Vong2.pptx
@@ -2,22 +2,22 @@
 <file path=ppt/presentation.xml><?xml version="1.0" encoding="utf-8"?>
 <p:presentation xmlns:p="http://schemas.openxmlformats.org/presentationml/2006/main">
   <p:sldMasterIdLst>
-    <p:sldMasterId xmlns:r="http://schemas.openxmlformats.org/officeDocument/2006/relationships" id="2147483648" r:id="Rc4c8ada18a084217"/>
+    <p:sldMasterId xmlns:r="http://schemas.openxmlformats.org/officeDocument/2006/relationships" id="2147483648" r:id="R422baa19cf884ee1"/>
   </p:sldMasterIdLst>
   <p:notesMasterIdLst>
-    <p:notesMasterId xmlns:r="http://schemas.openxmlformats.org/officeDocument/2006/relationships" r:id="Rebf300bd270c45fc"/>
+    <p:notesMasterId xmlns:r="http://schemas.openxmlformats.org/officeDocument/2006/relationships" r:id="Rc1f7edda7bc24093"/>
   </p:notesMasterIdLst>
   <p:sldIdLst>
-    <p:sldId xmlns:r="http://schemas.openxmlformats.org/officeDocument/2006/relationships" id="256" r:id="Rdac37188866f4c3c"/>
-    <p:sldId xmlns:r="http://schemas.openxmlformats.org/officeDocument/2006/relationships" id="257" r:id="R39f31be956a149ce"/>
-    <p:sldId xmlns:r="http://schemas.openxmlformats.org/officeDocument/2006/relationships" id="258" r:id="Rfea8df2107ca4491"/>
-    <p:sldId xmlns:r="http://schemas.openxmlformats.org/officeDocument/2006/relationships" id="259" r:id="R2256cb1a255244f7"/>
-    <p:sldId xmlns:r="http://schemas.openxmlformats.org/officeDocument/2006/relationships" id="260" r:id="R314ed30a87254a73"/>
-    <p:sldId xmlns:r="http://schemas.openxmlformats.org/officeDocument/2006/relationships" id="261" r:id="R3fc01e511b154e7d"/>
-    <p:sldId xmlns:r="http://schemas.openxmlformats.org/officeDocument/2006/relationships" id="262" r:id="R40e458dd089945a5"/>
-    <p:sldId xmlns:r="http://schemas.openxmlformats.org/officeDocument/2006/relationships" id="263" r:id="R8a5107fabf634661"/>
-    <p:sldId xmlns:r="http://schemas.openxmlformats.org/officeDocument/2006/relationships" id="264" r:id="R86a255d7ced84461"/>
-    <p:sldId xmlns:r="http://schemas.openxmlformats.org/officeDocument/2006/relationships" id="265" r:id="R08a729e0536142f8"/>
+    <p:sldId xmlns:r="http://schemas.openxmlformats.org/officeDocument/2006/relationships" id="256" r:id="R803a81db62874c80"/>
+    <p:sldId xmlns:r="http://schemas.openxmlformats.org/officeDocument/2006/relationships" id="257" r:id="R614a0ff24d4e49b1"/>
+    <p:sldId xmlns:r="http://schemas.openxmlformats.org/officeDocument/2006/relationships" id="258" r:id="R4e3622fa31dd4b9c"/>
+    <p:sldId xmlns:r="http://schemas.openxmlformats.org/officeDocument/2006/relationships" id="259" r:id="R227000874a884eba"/>
+    <p:sldId xmlns:r="http://schemas.openxmlformats.org/officeDocument/2006/relationships" id="260" r:id="Rea2856f70da544d5"/>
+    <p:sldId xmlns:r="http://schemas.openxmlformats.org/officeDocument/2006/relationships" id="261" r:id="R19bf43439ddd4726"/>
+    <p:sldId xmlns:r="http://schemas.openxmlformats.org/officeDocument/2006/relationships" id="262" r:id="Rc9ebf8222c1647f4"/>
+    <p:sldId xmlns:r="http://schemas.openxmlformats.org/officeDocument/2006/relationships" id="263" r:id="R4427d72c7ecc4f90"/>
+    <p:sldId xmlns:r="http://schemas.openxmlformats.org/officeDocument/2006/relationships" id="264" r:id="R09222c8b8f224640"/>
+    <p:sldId xmlns:r="http://schemas.openxmlformats.org/officeDocument/2006/relationships" id="265" r:id="R9f5626f9c7b7416a"/>
   </p:sldIdLst>
   <p:sldSz cx="12192000" cy="6858000"/>
   <p:notesSz cx="6858000" cy="9144000"/>
@@ -764,6 +764,11 @@
               <a:t>- android/voice/README.md</a:t>
             </a:r>
           </a:p>
+          <a:p xmlns:a="http://schemas.openxmlformats.org/drawingml/2006/main">
+            <a:r>
+              <a:t>- vong2/25-LECH-KIEN-TRUC-VOICE-PIPELINE.md</a:t>
+            </a:r>
+          </a:p>
         </p:txBody>
       </p:sp>
       <p:sp>
@@ -852,6 +857,11 @@
           <a:p xmlns:a="http://schemas.openxmlformats.org/drawingml/2006/main">
             <a:r>
               <a:t>- automotive/README.md</a:t>
+            </a:r>
+          </a:p>
+          <a:p xmlns:a="http://schemas.openxmlformats.org/drawingml/2006/main">
+            <a:r>
+              <a:t>- vong2/25-LECH-KIEN-TRUC-VOICE-PIPELINE.md</a:t>
             </a:r>
           </a:p>
         </p:txBody>
@@ -1339,7 +1349,7 @@
   </p:cSld>
   <p:clrMap bg1="lt1" tx1="dk1" bg2="lt2" tx2="dk2" accent1="accent1" accent2="accent2" accent3="accent3" accent4="accent4" accent5="accent5" accent6="accent6" hlink="hlink" folHlink="folHlink"/>
   <p:sldLayoutIdLst>
-    <p:sldLayoutId xmlns:r="http://schemas.openxmlformats.org/officeDocument/2006/relationships" id="2147483649" r:id="Rb7f2d38cf9134ffc"/>
+    <p:sldLayoutId xmlns:r="http://schemas.openxmlformats.org/officeDocument/2006/relationships" id="2147483649" r:id="R500d0506fd004b8e"/>
   </p:sldLayoutIdLst>
   <p:hf sldNum="0" hdr="0" ftr="0" dt="0"/>
   <p:txStyles>
@@ -1947,7 +1957,7 @@
           <p:nvPr/>
         </p:nvPicPr>
         <p:blipFill>
-          <a:blip xmlns:r="http://schemas.openxmlformats.org/officeDocument/2006/relationships" xmlns:a="http://schemas.openxmlformats.org/drawingml/2006/main" r:embed="R80556c1ed26e4e96"/>
+          <a:blip xmlns:r="http://schemas.openxmlformats.org/officeDocument/2006/relationships" xmlns:a="http://schemas.openxmlformats.org/drawingml/2006/main" r:embed="Rc7ada5aa716a4ffd"/>
           <a:stretch xmlns:a="http://schemas.openxmlformats.org/drawingml/2006/main">
             <a:fillRect l="0" t="0" r="0" b="0"/>
           </a:stretch>
@@ -1998,7 +2008,7 @@
           <p:nvPr/>
         </p:nvPicPr>
         <p:blipFill>
-          <a:blip xmlns:r="http://schemas.openxmlformats.org/officeDocument/2006/relationships" xmlns:a="http://schemas.openxmlformats.org/drawingml/2006/main" r:embed="R90ab303bf91047de"/>
+          <a:blip xmlns:r="http://schemas.openxmlformats.org/officeDocument/2006/relationships" xmlns:a="http://schemas.openxmlformats.org/drawingml/2006/main" r:embed="Rf3c93912eb424320"/>
           <a:stretch xmlns:a="http://schemas.openxmlformats.org/drawingml/2006/main">
             <a:fillRect l="0" t="0" r="0" b="0"/>
           </a:stretch>
@@ -2049,7 +2059,7 @@
           <p:nvPr/>
         </p:nvPicPr>
         <p:blipFill>
-          <a:blip xmlns:r="http://schemas.openxmlformats.org/officeDocument/2006/relationships" xmlns:a="http://schemas.openxmlformats.org/drawingml/2006/main" r:embed="Rfa5f9a2d139e47df"/>
+          <a:blip xmlns:r="http://schemas.openxmlformats.org/officeDocument/2006/relationships" xmlns:a="http://schemas.openxmlformats.org/drawingml/2006/main" r:embed="Rbe64e9baac6f40d7"/>
           <a:stretch xmlns:a="http://schemas.openxmlformats.org/drawingml/2006/main">
             <a:fillRect l="0" t="0" r="0" b="0"/>
           </a:stretch>
@@ -2467,7 +2477,7 @@
           <p:nvPr/>
         </p:nvPicPr>
         <p:blipFill>
-          <a:blip xmlns:r="http://schemas.openxmlformats.org/officeDocument/2006/relationships" xmlns:a="http://schemas.openxmlformats.org/drawingml/2006/main" r:embed="R907a65b71f154e58"/>
+          <a:blip xmlns:r="http://schemas.openxmlformats.org/officeDocument/2006/relationships" xmlns:a="http://schemas.openxmlformats.org/drawingml/2006/main" r:embed="R9802308d66124be5"/>
           <a:stretch xmlns:a="http://schemas.openxmlformats.org/drawingml/2006/main">
             <a:fillRect l="0" t="0" r="0" b="0"/>
           </a:stretch>
@@ -2998,7 +3008,7 @@
           <p:nvPr/>
         </p:nvPicPr>
         <p:blipFill>
-          <a:blip xmlns:r="http://schemas.openxmlformats.org/officeDocument/2006/relationships" xmlns:a="http://schemas.openxmlformats.org/drawingml/2006/main" r:embed="R5de6832d1964412d"/>
+          <a:blip xmlns:r="http://schemas.openxmlformats.org/officeDocument/2006/relationships" xmlns:a="http://schemas.openxmlformats.org/drawingml/2006/main" r:embed="R8f20043b364d4b70"/>
           <a:stretch xmlns:a="http://schemas.openxmlformats.org/drawingml/2006/main">
             <a:fillRect l="0" t="0" r="0" b="0"/>
           </a:stretch>
@@ -4179,7 +4189,7 @@
                 <a:ea typeface="Arial"/>
                 <a:cs typeface="Arial"/>
               </a:rPr>
-              <a:t>Nhấn nói → Silero VAD chốt cuối câu → ASR → grammar router → gateway → TTS. Mỗi lượt có trace theo stage; timeout và lỗi không được ghi thành công. Core chạy offline; ASR có boundary để đổi deployment mà không sửa agent.</a:t>
+              <a:t>Nhấn nói → Vosk tự thu và tự chốt cuối câu → grammar router → gateway → TTS/HMI. Silero VAD và AsrClient container đã có module/test nhưng chưa cắm. Mỗi lượt vẫn có trace; timeout và lỗi không được ghi thành công.</a:t>
             </a:r>
           </a:p>
         </p:txBody>
@@ -4262,7 +4272,7 @@
           <p:nvPr/>
         </p:nvPicPr>
         <p:blipFill>
-          <a:blip xmlns:r="http://schemas.openxmlformats.org/officeDocument/2006/relationships" xmlns:a="http://schemas.openxmlformats.org/drawingml/2006/main" r:embed="R1b7cd10bb54d471c"/>
+          <a:blip xmlns:r="http://schemas.openxmlformats.org/officeDocument/2006/relationships" xmlns:a="http://schemas.openxmlformats.org/drawingml/2006/main" r:embed="R58cbc7a2729c402e"/>
           <a:stretch xmlns:a="http://schemas.openxmlformats.org/drawingml/2006/main">
             <a:fillRect l="0" t="0" r="0" b="0"/>
           </a:stretch>
@@ -4549,7 +4559,7 @@
                 <a:ea typeface="Arial"/>
                 <a:cs typeface="Arial"/>
               </a:rPr>
-              <a:t>KIẾN TRÚC TÁCH RỜI, ĐO ĐƯỢC, THAY ĐƯỢC</a:t>
+              <a:t>KIẾN TRÚC ĐÍCH VÀ ĐƯỜNG CHẠY THỰC TẾ</a:t>
             </a:r>
           </a:p>
         </p:txBody>
@@ -4639,7 +4649,7 @@
                 <a:ea typeface="Arial"/>
                 <a:cs typeface="Arial"/>
               </a:rPr>
-              <a:t>Core voice đã tách thành các boundary có thể kiểm thử độc lập:</a:t>
+              <a:t>Phân biệt thành phần đang chạy trong APK với module đích đã có source/JVM:</a:t>
             </a:r>
           </a:p>
         </p:txBody>
@@ -4722,7 +4732,7 @@
           <p:nvPr/>
         </p:nvPicPr>
         <p:blipFill>
-          <a:blip xmlns:r="http://schemas.openxmlformats.org/officeDocument/2006/relationships" xmlns:a="http://schemas.openxmlformats.org/drawingml/2006/main" r:embed="Rbbbba38536f1484b"/>
+          <a:blip xmlns:r="http://schemas.openxmlformats.org/officeDocument/2006/relationships" xmlns:a="http://schemas.openxmlformats.org/drawingml/2006/main" r:embed="R1ea3c6f0412e4b0c"/>
           <a:stretch xmlns:a="http://schemas.openxmlformats.org/drawingml/2006/main">
             <a:fillRect l="0" t="0" r="0" b="0"/>
           </a:stretch>
@@ -4777,7 +4787,7 @@
                 <a:ea typeface="Arial"/>
                 <a:cs typeface="Arial"/>
               </a:rPr>
-              <a:t>Mic / PTT</a:t>
+              <a:t>Mic + Vosk</a:t>
             </a:r>
           </a:p>
         </p:txBody>
@@ -4825,7 +4835,7 @@
                 <a:ea typeface="Arial"/>
                 <a:cs typeface="Arial"/>
               </a:rPr>
-              <a:t>PCM 16 kHz mono</a:t>
+              <a:t>AudioRecord · tự endpoint</a:t>
             </a:r>
           </a:p>
         </p:txBody>
@@ -4899,7 +4909,7 @@
                 <a:ea typeface="Arial"/>
                 <a:cs typeface="Arial"/>
               </a:rPr>
-              <a:t>ĐÃ TÍCH HỢP</a:t>
+              <a:t>ĐANG CHẠY APK</a:t>
             </a:r>
           </a:p>
         </p:txBody>
@@ -5009,7 +5019,7 @@
           <p:nvPr/>
         </p:nvPicPr>
         <p:blipFill>
-          <a:blip xmlns:r="http://schemas.openxmlformats.org/officeDocument/2006/relationships" xmlns:a="http://schemas.openxmlformats.org/drawingml/2006/main" r:embed="R3bc61c10b91948f5"/>
+          <a:blip xmlns:r="http://schemas.openxmlformats.org/officeDocument/2006/relationships" xmlns:a="http://schemas.openxmlformats.org/drawingml/2006/main" r:embed="R808bd7dc3dea4563"/>
           <a:stretch xmlns:a="http://schemas.openxmlformats.org/drawingml/2006/main">
             <a:fillRect l="0" t="0" r="0" b="0"/>
           </a:stretch>
@@ -5064,7 +5074,7 @@
                 <a:ea typeface="Arial"/>
                 <a:cs typeface="Arial"/>
               </a:rPr>
-              <a:t>VAD + ASR</a:t>
+              <a:t>VAD + ASR đích</a:t>
             </a:r>
           </a:p>
         </p:txBody>
@@ -5112,7 +5122,7 @@
                 <a:ea typeface="Arial"/>
                 <a:cs typeface="Arial"/>
               </a:rPr>
-              <a:t>Silero ONNX · Vosk / AsrClient</a:t>
+              <a:t>Silero · AsrClient container</a:t>
             </a:r>
           </a:p>
         </p:txBody>
@@ -5186,7 +5196,7 @@
                 <a:ea typeface="Arial"/>
                 <a:cs typeface="Arial"/>
               </a:rPr>
-              <a:t>SOURCE/JVM</a:t>
+              <a:t>CHƯA CẮM</a:t>
             </a:r>
           </a:p>
         </p:txBody>
@@ -5296,7 +5306,7 @@
           <p:nvPr/>
         </p:nvPicPr>
         <p:blipFill>
-          <a:blip xmlns:r="http://schemas.openxmlformats.org/officeDocument/2006/relationships" xmlns:a="http://schemas.openxmlformats.org/drawingml/2006/main" r:embed="R8e2c3180bc0f4028"/>
+          <a:blip xmlns:r="http://schemas.openxmlformats.org/officeDocument/2006/relationships" xmlns:a="http://schemas.openxmlformats.org/drawingml/2006/main" r:embed="R2fc8633b35c54aaf"/>
           <a:stretch xmlns:a="http://schemas.openxmlformats.org/drawingml/2006/main">
             <a:fillRect l="0" t="0" r="0" b="0"/>
           </a:stretch>
@@ -5473,7 +5483,7 @@
                 <a:ea typeface="Arial"/>
                 <a:cs typeface="Arial"/>
               </a:rPr>
-              <a:t>SOURCE/JVM</a:t>
+              <a:t>ĐANG CHẠY APK</a:t>
             </a:r>
           </a:p>
         </p:txBody>
@@ -5583,7 +5593,7 @@
           <p:nvPr/>
         </p:nvPicPr>
         <p:blipFill>
-          <a:blip xmlns:r="http://schemas.openxmlformats.org/officeDocument/2006/relationships" xmlns:a="http://schemas.openxmlformats.org/drawingml/2006/main" r:embed="R719d116e6a564495"/>
+          <a:blip xmlns:r="http://schemas.openxmlformats.org/officeDocument/2006/relationships" xmlns:a="http://schemas.openxmlformats.org/drawingml/2006/main" r:embed="R46792f10dd654fe7"/>
           <a:stretch xmlns:a="http://schemas.openxmlformats.org/drawingml/2006/main">
             <a:fillRect l="0" t="0" r="0" b="0"/>
           </a:stretch>
@@ -5638,7 +5648,7 @@
                 <a:ea typeface="Arial"/>
                 <a:cs typeface="Arial"/>
               </a:rPr>
-              <a:t>SERVICE + GUARD</a:t>
+              <a:t>SERVICE / GUARD</a:t>
             </a:r>
           </a:p>
         </p:txBody>
@@ -5760,7 +5770,7 @@
                 <a:ea typeface="Arial"/>
                 <a:cs typeface="Arial"/>
               </a:rPr>
-              <a:t>CHỜ TÍCH HỢP</a:t>
+              <a:t>GUARD CHƯA CÓ</a:t>
             </a:r>
           </a:p>
         </p:txBody>
@@ -5870,7 +5880,7 @@
           <p:nvPr/>
         </p:nvPicPr>
         <p:blipFill>
-          <a:blip xmlns:r="http://schemas.openxmlformats.org/officeDocument/2006/relationships" xmlns:a="http://schemas.openxmlformats.org/drawingml/2006/main" r:embed="R91908dad0b134d6b"/>
+          <a:blip xmlns:r="http://schemas.openxmlformats.org/officeDocument/2006/relationships" xmlns:a="http://schemas.openxmlformats.org/drawingml/2006/main" r:embed="Raebb9cf4825e435f"/>
           <a:stretch xmlns:a="http://schemas.openxmlformats.org/drawingml/2006/main">
             <a:fillRect l="0" t="0" r="0" b="0"/>
           </a:stretch>
@@ -6157,7 +6167,7 @@
           <p:nvPr/>
         </p:nvPicPr>
         <p:blipFill>
-          <a:blip xmlns:r="http://schemas.openxmlformats.org/officeDocument/2006/relationships" xmlns:a="http://schemas.openxmlformats.org/drawingml/2006/main" r:embed="Ra992f3864a6c4e56"/>
+          <a:blip xmlns:r="http://schemas.openxmlformats.org/officeDocument/2006/relationships" xmlns:a="http://schemas.openxmlformats.org/drawingml/2006/main" r:embed="R7f15133ef2b44adb"/>
           <a:stretch xmlns:a="http://schemas.openxmlformats.org/drawingml/2006/main">
             <a:fillRect l="0" t="0" r="0" b="0"/>
           </a:stretch>
@@ -6334,7 +6344,7 @@
                 <a:ea typeface="Arial"/>
                 <a:cs typeface="Arial"/>
               </a:rPr>
-              <a:t>SOURCE/JVM</a:t>
+              <a:t>ĐANG CHẠY APK</a:t>
             </a:r>
           </a:p>
         </p:txBody>
@@ -6424,7 +6434,7 @@
                 <a:ea typeface="Arial"/>
                 <a:cs typeface="Arial"/>
               </a:rPr>
-              <a:t>Trace: speech_end → asr_done → intent_done → guard_done → exec_done → tts_start. Timeout/lỗi giữ đúng stage; TTS chỉ xác nhận sau CommandResult.Applied.</a:t>
+              <a:t>Đường chạy APK: speech_start → speech_end → asr_done → nlu_done → exec_done → tts_start. guard_done chưa có; Silero VAD và AsrClient container chưa tham gia luồng.</a:t>
             </a:r>
           </a:p>
         </p:txBody>
@@ -6469,7 +6479,7 @@
                 <a:ea typeface="Arial"/>
                 <a:cs typeface="Arial"/>
               </a:rPr>
-              <a:t>Boundary quan trọng:</a:t>
+              <a:t>Boundary có sẵn, nhưng trạng thái khác nhau:</a:t>
             </a:r>
           </a:p>
         </p:txBody>
@@ -6884,7 +6894,7 @@
                 <a:ea typeface="Arial"/>
                 <a:cs typeface="Arial"/>
               </a:rPr>
-              <a:t>Mỗi boundary đổi được độc lập; không cần sửa core agent.</a:t>
+              <a:t>Chỉ so hai engine sau khi dùng chung một dòng PCM và cùng định nghĩa endpoint.</a:t>
             </a:r>
           </a:p>
         </p:txBody>
@@ -7241,7 +7251,7 @@
           <p:nvPr/>
         </p:nvPicPr>
         <p:blipFill>
-          <a:blip xmlns:r="http://schemas.openxmlformats.org/officeDocument/2006/relationships" xmlns:a="http://schemas.openxmlformats.org/drawingml/2006/main" r:embed="R8b1df6b517004b20"/>
+          <a:blip xmlns:r="http://schemas.openxmlformats.org/officeDocument/2006/relationships" xmlns:a="http://schemas.openxmlformats.org/drawingml/2006/main" r:embed="R2b0149d0084a4df8"/>
           <a:stretch xmlns:a="http://schemas.openxmlformats.org/drawingml/2006/main">
             <a:fillRect l="0" t="0" r="0" b="0"/>
           </a:stretch>
@@ -7478,7 +7488,7 @@
           <p:nvPr/>
         </p:nvPicPr>
         <p:blipFill>
-          <a:blip xmlns:r="http://schemas.openxmlformats.org/officeDocument/2006/relationships" xmlns:a="http://schemas.openxmlformats.org/drawingml/2006/main" r:embed="R005b8dd6db8d417d"/>
+          <a:blip xmlns:r="http://schemas.openxmlformats.org/officeDocument/2006/relationships" xmlns:a="http://schemas.openxmlformats.org/drawingml/2006/main" r:embed="Rf0efd0fe969141d8"/>
           <a:stretch xmlns:a="http://schemas.openxmlformats.org/drawingml/2006/main">
             <a:fillRect l="0" t="0" r="0" b="0"/>
           </a:stretch>
@@ -7715,7 +7725,7 @@
           <p:nvPr/>
         </p:nvPicPr>
         <p:blipFill>
-          <a:blip xmlns:r="http://schemas.openxmlformats.org/officeDocument/2006/relationships" xmlns:a="http://schemas.openxmlformats.org/drawingml/2006/main" r:embed="Rbeef4c00a8574bb4"/>
+          <a:blip xmlns:r="http://schemas.openxmlformats.org/officeDocument/2006/relationships" xmlns:a="http://schemas.openxmlformats.org/drawingml/2006/main" r:embed="R1e6a75c69cb34b1e"/>
           <a:stretch xmlns:a="http://schemas.openxmlformats.org/drawingml/2006/main">
             <a:fillRect l="0" t="0" r="0" b="0"/>
           </a:stretch>
@@ -8289,7 +8299,7 @@
           <p:nvPr/>
         </p:nvPicPr>
         <p:blipFill>
-          <a:blip xmlns:r="http://schemas.openxmlformats.org/officeDocument/2006/relationships" xmlns:a="http://schemas.openxmlformats.org/drawingml/2006/main" r:embed="R555c807012b34e28"/>
+          <a:blip xmlns:r="http://schemas.openxmlformats.org/officeDocument/2006/relationships" xmlns:a="http://schemas.openxmlformats.org/drawingml/2006/main" r:embed="Rbcf014f4e2ca41fc"/>
           <a:stretch xmlns:a="http://schemas.openxmlformats.org/drawingml/2006/main">
             <a:fillRect l="0" t="0" r="0" b="0"/>
           </a:stretch>
@@ -8361,7 +8371,7 @@
           <p:nvPr/>
         </p:nvPicPr>
         <p:blipFill>
-          <a:blip xmlns:r="http://schemas.openxmlformats.org/officeDocument/2006/relationships" xmlns:a="http://schemas.openxmlformats.org/drawingml/2006/main" r:embed="Rd0071761a0644b88"/>
+          <a:blip xmlns:r="http://schemas.openxmlformats.org/officeDocument/2006/relationships" xmlns:a="http://schemas.openxmlformats.org/drawingml/2006/main" r:embed="Rff36604895a24978"/>
           <a:stretch xmlns:a="http://schemas.openxmlformats.org/drawingml/2006/main">
             <a:fillRect l="0" t="0" r="0" b="0"/>
           </a:stretch>
@@ -8433,7 +8443,7 @@
           <p:nvPr/>
         </p:nvPicPr>
         <p:blipFill>
-          <a:blip xmlns:r="http://schemas.openxmlformats.org/officeDocument/2006/relationships" xmlns:a="http://schemas.openxmlformats.org/drawingml/2006/main" r:embed="R0b4bc9673b4941eb"/>
+          <a:blip xmlns:r="http://schemas.openxmlformats.org/officeDocument/2006/relationships" xmlns:a="http://schemas.openxmlformats.org/drawingml/2006/main" r:embed="Rd4727d6f8cf74c1b"/>
           <a:stretch xmlns:a="http://schemas.openxmlformats.org/drawingml/2006/main">
             <a:fillRect l="0" t="0" r="0" b="0"/>
           </a:stretch>
@@ -8505,7 +8515,7 @@
           <p:nvPr/>
         </p:nvPicPr>
         <p:blipFill>
-          <a:blip xmlns:r="http://schemas.openxmlformats.org/officeDocument/2006/relationships" xmlns:a="http://schemas.openxmlformats.org/drawingml/2006/main" r:embed="R84ff4ee08fd4480d"/>
+          <a:blip xmlns:r="http://schemas.openxmlformats.org/officeDocument/2006/relationships" xmlns:a="http://schemas.openxmlformats.org/drawingml/2006/main" r:embed="R0e6716e173274e89"/>
           <a:stretch xmlns:a="http://schemas.openxmlformats.org/drawingml/2006/main">
             <a:fillRect l="0" t="0" r="0" b="0"/>
           </a:stretch>
@@ -8577,7 +8587,7 @@
           <p:nvPr/>
         </p:nvPicPr>
         <p:blipFill>
-          <a:blip xmlns:r="http://schemas.openxmlformats.org/officeDocument/2006/relationships" xmlns:a="http://schemas.openxmlformats.org/drawingml/2006/main" r:embed="R5ee5787558444eee"/>
+          <a:blip xmlns:r="http://schemas.openxmlformats.org/officeDocument/2006/relationships" xmlns:a="http://schemas.openxmlformats.org/drawingml/2006/main" r:embed="R865956f90b984f3a"/>
           <a:stretch xmlns:a="http://schemas.openxmlformats.org/drawingml/2006/main">
             <a:fillRect l="0" t="0" r="0" b="0"/>
           </a:stretch>
@@ -9340,7 +9350,7 @@
           <p:nvPr/>
         </p:nvPicPr>
         <p:blipFill>
-          <a:blip xmlns:r="http://schemas.openxmlformats.org/officeDocument/2006/relationships" xmlns:a="http://schemas.openxmlformats.org/drawingml/2006/main" r:embed="Rf76f098d60574af2"/>
+          <a:blip xmlns:r="http://schemas.openxmlformats.org/officeDocument/2006/relationships" xmlns:a="http://schemas.openxmlformats.org/drawingml/2006/main" r:embed="Rdc2bc001e1434d75"/>
           <a:stretch xmlns:a="http://schemas.openxmlformats.org/drawingml/2006/main">
             <a:fillRect l="0" t="0" r="0" b="0"/>
           </a:stretch>
@@ -9412,7 +9422,7 @@
           <p:nvPr/>
         </p:nvPicPr>
         <p:blipFill>
-          <a:blip xmlns:r="http://schemas.openxmlformats.org/officeDocument/2006/relationships" xmlns:a="http://schemas.openxmlformats.org/drawingml/2006/main" r:embed="R01c5eec9d8ea40af"/>
+          <a:blip xmlns:r="http://schemas.openxmlformats.org/officeDocument/2006/relationships" xmlns:a="http://schemas.openxmlformats.org/drawingml/2006/main" r:embed="R8574177018bd4faa"/>
           <a:stretch xmlns:a="http://schemas.openxmlformats.org/drawingml/2006/main">
             <a:fillRect l="0" t="0" r="0" b="0"/>
           </a:stretch>
@@ -9484,7 +9494,7 @@
           <p:nvPr/>
         </p:nvPicPr>
         <p:blipFill>
-          <a:blip xmlns:r="http://schemas.openxmlformats.org/officeDocument/2006/relationships" xmlns:a="http://schemas.openxmlformats.org/drawingml/2006/main" r:embed="Recceb4eb535649c8"/>
+          <a:blip xmlns:r="http://schemas.openxmlformats.org/officeDocument/2006/relationships" xmlns:a="http://schemas.openxmlformats.org/drawingml/2006/main" r:embed="R35c7d3b24e614291"/>
           <a:stretch xmlns:a="http://schemas.openxmlformats.org/drawingml/2006/main">
             <a:fillRect l="0" t="0" r="0" b="0"/>
           </a:stretch>
@@ -9556,7 +9566,7 @@
           <p:nvPr/>
         </p:nvPicPr>
         <p:blipFill>
-          <a:blip xmlns:r="http://schemas.openxmlformats.org/officeDocument/2006/relationships" xmlns:a="http://schemas.openxmlformats.org/drawingml/2006/main" r:embed="Rbe5a4e8feccb4c15"/>
+          <a:blip xmlns:r="http://schemas.openxmlformats.org/officeDocument/2006/relationships" xmlns:a="http://schemas.openxmlformats.org/drawingml/2006/main" r:embed="R30c6ac32ca9048c4"/>
           <a:stretch xmlns:a="http://schemas.openxmlformats.org/drawingml/2006/main">
             <a:fillRect l="0" t="0" r="0" b="0"/>
           </a:stretch>
@@ -9628,7 +9638,7 @@
           <p:nvPr/>
         </p:nvPicPr>
         <p:blipFill>
-          <a:blip xmlns:r="http://schemas.openxmlformats.org/officeDocument/2006/relationships" xmlns:a="http://schemas.openxmlformats.org/drawingml/2006/main" r:embed="Rc8d4a36916fe4c2b"/>
+          <a:blip xmlns:r="http://schemas.openxmlformats.org/officeDocument/2006/relationships" xmlns:a="http://schemas.openxmlformats.org/drawingml/2006/main" r:embed="Re5970195599543b8"/>
           <a:stretch xmlns:a="http://schemas.openxmlformats.org/drawingml/2006/main">
             <a:fillRect l="0" t="0" r="0" b="0"/>
           </a:stretch>
@@ -10373,7 +10383,7 @@
           <p:nvPr/>
         </p:nvPicPr>
         <p:blipFill>
-          <a:blip xmlns:r="http://schemas.openxmlformats.org/officeDocument/2006/relationships" xmlns:a="http://schemas.openxmlformats.org/drawingml/2006/main" r:embed="Re09f8096c1e3436d"/>
+          <a:blip xmlns:r="http://schemas.openxmlformats.org/officeDocument/2006/relationships" xmlns:a="http://schemas.openxmlformats.org/drawingml/2006/main" r:embed="R2b592e05e3854527"/>
           <a:stretch xmlns:a="http://schemas.openxmlformats.org/drawingml/2006/main">
             <a:fillRect l="0" t="0" r="0" b="0"/>
           </a:stretch>
@@ -10559,7 +10569,7 @@
           <p:nvPr/>
         </p:nvPicPr>
         <p:blipFill>
-          <a:blip xmlns:r="http://schemas.openxmlformats.org/officeDocument/2006/relationships" xmlns:a="http://schemas.openxmlformats.org/drawingml/2006/main" r:embed="R1353dc50b8df4485"/>
+          <a:blip xmlns:r="http://schemas.openxmlformats.org/officeDocument/2006/relationships" xmlns:a="http://schemas.openxmlformats.org/drawingml/2006/main" r:embed="Re27c85a792664df9"/>
           <a:stretch xmlns:a="http://schemas.openxmlformats.org/drawingml/2006/main">
             <a:fillRect l="0" t="0" r="0" b="0"/>
           </a:stretch>
@@ -10745,7 +10755,7 @@
           <p:nvPr/>
         </p:nvPicPr>
         <p:blipFill>
-          <a:blip xmlns:r="http://schemas.openxmlformats.org/officeDocument/2006/relationships" xmlns:a="http://schemas.openxmlformats.org/drawingml/2006/main" r:embed="R5a72b4f6b2a94d49"/>
+          <a:blip xmlns:r="http://schemas.openxmlformats.org/officeDocument/2006/relationships" xmlns:a="http://schemas.openxmlformats.org/drawingml/2006/main" r:embed="R4d321e9528b34424"/>
           <a:stretch xmlns:a="http://schemas.openxmlformats.org/drawingml/2006/main">
             <a:fillRect l="0" t="0" r="0" b="0"/>
           </a:stretch>

</xml_diff>